<commit_message>
fix(ppt): adjust card dimensions, paddings, and alignment across all slides
</commit_message>
<xml_diff>
--- a/PocketOps_Presentation.pptx
+++ b/PocketOps_Presentation.pptx
@@ -1417,24 +1417,24 @@
         </p:nvSpPr>
         <p:spPr>
           <a:xfrm>
-            <a:off x="914400" y="1371600"/>
-            <a:ext cx="10058400" cy="365760"/>
-          </a:xfrm>
-          <a:prstGeom prst="rect">
-            <a:avLst/>
-          </a:prstGeom>
-          <a:noFill/>
-          <a:ln/>
-        </p:spPr>
-        <p:txBody>
-          <a:bodyPr wrap="square" rtlCol="0" anchor="ctr"/>
-          <a:lstStyle/>
-          <a:p>
-            <a:pPr indent="0" marL="0">
-              <a:buNone/>
-            </a:pPr>
-            <a:r>
-              <a:rPr lang="en-US" sz="1200" b="1" dirty="0">
+            <a:off x="731520" y="1188720"/>
+            <a:ext cx="10725912" cy="320040"/>
+          </a:xfrm>
+          <a:prstGeom prst="rect">
+            <a:avLst/>
+          </a:prstGeom>
+          <a:noFill/>
+          <a:ln/>
+        </p:spPr>
+        <p:txBody>
+          <a:bodyPr wrap="square" rtlCol="0" anchor="ctr"/>
+          <a:lstStyle/>
+          <a:p>
+            <a:pPr indent="0" marL="0">
+              <a:buNone/>
+            </a:pPr>
+            <a:r>
+              <a:rPr lang="en-US" sz="1100" b="1" dirty="0">
                 <a:solidFill>
                   <a:srgbClr val="FF5500"/>
                 </a:solidFill>
@@ -1444,7 +1444,7 @@
               </a:rPr>
               <a:t>iQOO HACKATHON 2026 · DEVELOPER TOOLS &amp; OPEN INNOVATION</a:t>
             </a:r>
-            <a:endParaRPr lang="en-US" sz="1200" dirty="0"/>
+            <a:endParaRPr lang="en-US" sz="1100" dirty="0"/>
           </a:p>
         </p:txBody>
       </p:sp>
@@ -1456,8 +1456,8 @@
         </p:nvSpPr>
         <p:spPr>
           <a:xfrm>
-            <a:off x="914400" y="1828800"/>
-            <a:ext cx="10058400" cy="1005840"/>
+            <a:off x="731520" y="1554480"/>
+            <a:ext cx="10725912" cy="1005840"/>
           </a:xfrm>
           <a:prstGeom prst="rect">
             <a:avLst/>
@@ -1495,8 +1495,8 @@
         </p:nvSpPr>
         <p:spPr>
           <a:xfrm>
-            <a:off x="914400" y="2834640"/>
-            <a:ext cx="10058400" cy="548640"/>
+            <a:off x="731520" y="2606040"/>
+            <a:ext cx="10725912" cy="502920"/>
           </a:xfrm>
           <a:prstGeom prst="rect">
             <a:avLst/>
@@ -1534,24 +1534,24 @@
         </p:nvSpPr>
         <p:spPr>
           <a:xfrm>
-            <a:off x="914400" y="3474720"/>
-            <a:ext cx="10058400" cy="457200"/>
-          </a:xfrm>
-          <a:prstGeom prst="rect">
-            <a:avLst/>
-          </a:prstGeom>
-          <a:noFill/>
-          <a:ln/>
-        </p:spPr>
-        <p:txBody>
-          <a:bodyPr wrap="square" rtlCol="0" anchor="ctr"/>
-          <a:lstStyle/>
-          <a:p>
-            <a:pPr indent="0" marL="0">
-              <a:buNone/>
-            </a:pPr>
-            <a:r>
-              <a:rPr lang="en-US" sz="1400" i="1" dirty="0">
+            <a:off x="731520" y="3200400"/>
+            <a:ext cx="10725912" cy="411480"/>
+          </a:xfrm>
+          <a:prstGeom prst="rect">
+            <a:avLst/>
+          </a:prstGeom>
+          <a:noFill/>
+          <a:ln/>
+        </p:spPr>
+        <p:txBody>
+          <a:bodyPr wrap="square" rtlCol="0" anchor="ctr"/>
+          <a:lstStyle/>
+          <a:p>
+            <a:pPr indent="0" marL="0">
+              <a:buNone/>
+            </a:pPr>
+            <a:r>
+              <a:rPr lang="en-US" sz="1350" i="1" dirty="0">
                 <a:solidFill>
                   <a:srgbClr val="94A3B8"/>
                 </a:solidFill>
@@ -1561,7 +1561,7 @@
               </a:rPr>
               <a:t>"When one device fails, your work should never have to stop."</a:t>
             </a:r>
-            <a:endParaRPr lang="en-US" sz="1400" dirty="0"/>
+            <a:endParaRPr lang="en-US" sz="1350" dirty="0"/>
           </a:p>
         </p:txBody>
       </p:sp>
@@ -1573,12 +1573,12 @@
         </p:nvSpPr>
         <p:spPr>
           <a:xfrm>
-            <a:off x="914400" y="4206240"/>
-            <a:ext cx="4846320" cy="640080"/>
+            <a:off x="731520" y="3931920"/>
+            <a:ext cx="5166360" cy="777240"/>
           </a:xfrm>
           <a:prstGeom prst="roundRect">
             <a:avLst>
-              <a:gd name="adj" fmla="val 14286"/>
+              <a:gd name="adj" fmla="val 11765"/>
             </a:avLst>
           </a:prstGeom>
           <a:solidFill>
@@ -1586,7 +1586,7 @@
           </a:solidFill>
           <a:ln w="12700">
             <a:solidFill>
-              <a:srgbClr val="2A314A"/>
+              <a:srgbClr val="22283A"/>
             </a:solidFill>
             <a:prstDash val="solid"/>
           </a:ln>
@@ -1600,8 +1600,8 @@
         </p:nvSpPr>
         <p:spPr>
           <a:xfrm>
-            <a:off x="1051560" y="4206240"/>
-            <a:ext cx="4572000" cy="640080"/>
+            <a:off x="960120" y="4041648"/>
+            <a:ext cx="4709160" cy="548640"/>
           </a:xfrm>
           <a:prstGeom prst="rect">
             <a:avLst/>
@@ -1639,12 +1639,12 @@
         </p:nvSpPr>
         <p:spPr>
           <a:xfrm>
-            <a:off x="6035040" y="4206240"/>
-            <a:ext cx="4846320" cy="640080"/>
+            <a:off x="6172200" y="3931920"/>
+            <a:ext cx="5166360" cy="777240"/>
           </a:xfrm>
           <a:prstGeom prst="roundRect">
             <a:avLst>
-              <a:gd name="adj" fmla="val 14286"/>
+              <a:gd name="adj" fmla="val 11765"/>
             </a:avLst>
           </a:prstGeom>
           <a:solidFill>
@@ -1652,7 +1652,7 @@
           </a:solidFill>
           <a:ln w="12700">
             <a:solidFill>
-              <a:srgbClr val="2A314A"/>
+              <a:srgbClr val="22283A"/>
             </a:solidFill>
             <a:prstDash val="solid"/>
           </a:ln>
@@ -1666,8 +1666,8 @@
         </p:nvSpPr>
         <p:spPr>
           <a:xfrm>
-            <a:off x="6172200" y="4206240"/>
-            <a:ext cx="4572000" cy="640080"/>
+            <a:off x="6400800" y="4041648"/>
+            <a:ext cx="4709160" cy="548640"/>
           </a:xfrm>
           <a:prstGeom prst="rect">
             <a:avLst/>
@@ -1705,12 +1705,12 @@
         </p:nvSpPr>
         <p:spPr>
           <a:xfrm>
-            <a:off x="914400" y="5029200"/>
-            <a:ext cx="4846320" cy="640080"/>
+            <a:off x="731520" y="4937760"/>
+            <a:ext cx="5166360" cy="777240"/>
           </a:xfrm>
           <a:prstGeom prst="roundRect">
             <a:avLst>
-              <a:gd name="adj" fmla="val 14286"/>
+              <a:gd name="adj" fmla="val 11765"/>
             </a:avLst>
           </a:prstGeom>
           <a:solidFill>
@@ -1718,7 +1718,7 @@
           </a:solidFill>
           <a:ln w="12700">
             <a:solidFill>
-              <a:srgbClr val="2A314A"/>
+              <a:srgbClr val="22283A"/>
             </a:solidFill>
             <a:prstDash val="solid"/>
           </a:ln>
@@ -1732,8 +1732,8 @@
         </p:nvSpPr>
         <p:spPr>
           <a:xfrm>
-            <a:off x="1051560" y="5029200"/>
-            <a:ext cx="4572000" cy="640080"/>
+            <a:off x="960120" y="5047488"/>
+            <a:ext cx="4709160" cy="548640"/>
           </a:xfrm>
           <a:prstGeom prst="rect">
             <a:avLst/>
@@ -1771,12 +1771,12 @@
         </p:nvSpPr>
         <p:spPr>
           <a:xfrm>
-            <a:off x="6035040" y="5029200"/>
-            <a:ext cx="4846320" cy="640080"/>
+            <a:off x="6172200" y="4937760"/>
+            <a:ext cx="5166360" cy="777240"/>
           </a:xfrm>
           <a:prstGeom prst="roundRect">
             <a:avLst>
-              <a:gd name="adj" fmla="val 14286"/>
+              <a:gd name="adj" fmla="val 11765"/>
             </a:avLst>
           </a:prstGeom>
           <a:solidFill>
@@ -1784,7 +1784,7 @@
           </a:solidFill>
           <a:ln w="12700">
             <a:solidFill>
-              <a:srgbClr val="2A314A"/>
+              <a:srgbClr val="22283A"/>
             </a:solidFill>
             <a:prstDash val="solid"/>
           </a:ln>
@@ -1798,8 +1798,8 @@
         </p:nvSpPr>
         <p:spPr>
           <a:xfrm>
-            <a:off x="6172200" y="5029200"/>
-            <a:ext cx="4572000" cy="640080"/>
+            <a:off x="6400800" y="5047488"/>
+            <a:ext cx="4709160" cy="548640"/>
           </a:xfrm>
           <a:prstGeom prst="rect">
             <a:avLst/>
@@ -1870,7 +1870,7 @@
         <p:spPr>
           <a:xfrm>
             <a:off x="731520" y="365760"/>
-            <a:ext cx="7315200" cy="274320"/>
+            <a:ext cx="7315200" cy="228600"/>
           </a:xfrm>
           <a:prstGeom prst="rect">
             <a:avLst/>
@@ -1909,7 +1909,7 @@
         <p:spPr>
           <a:xfrm>
             <a:off x="731520" y="594360"/>
-            <a:ext cx="10515600" cy="548640"/>
+            <a:ext cx="10725912" cy="502920"/>
           </a:xfrm>
           <a:prstGeom prst="rect">
             <a:avLst/>
@@ -1947,24 +1947,24 @@
         </p:nvSpPr>
         <p:spPr>
           <a:xfrm>
-            <a:off x="731520" y="1143000"/>
-            <a:ext cx="10515600" cy="320040"/>
-          </a:xfrm>
-          <a:prstGeom prst="rect">
-            <a:avLst/>
-          </a:prstGeom>
-          <a:noFill/>
-          <a:ln/>
-        </p:spPr>
-        <p:txBody>
-          <a:bodyPr wrap="square" rtlCol="0" anchor="ctr"/>
-          <a:lstStyle/>
-          <a:p>
-            <a:pPr indent="0" marL="0">
-              <a:buNone/>
-            </a:pPr>
-            <a:r>
-              <a:rPr lang="en-US" sz="1200" dirty="0">
+            <a:off x="731520" y="1115568"/>
+            <a:ext cx="10725912" cy="320040"/>
+          </a:xfrm>
+          <a:prstGeom prst="rect">
+            <a:avLst/>
+          </a:prstGeom>
+          <a:noFill/>
+          <a:ln/>
+        </p:spPr>
+        <p:txBody>
+          <a:bodyPr wrap="square" rtlCol="0" anchor="ctr"/>
+          <a:lstStyle/>
+          <a:p>
+            <a:pPr indent="0" marL="0">
+              <a:buNone/>
+            </a:pPr>
+            <a:r>
+              <a:rPr lang="en-US" sz="1150" dirty="0">
                 <a:solidFill>
                   <a:srgbClr val="94A3B8"/>
                 </a:solidFill>
@@ -1972,9 +1972,9 @@
                 <a:ea typeface="Arial" pitchFamily="34" charset="-122"/>
                 <a:cs typeface="Arial" pitchFamily="34" charset="-120"/>
               </a:rPr>
-              <a:t>Why existing cloud IDEs and ecosystem continuity solutions fail developers during sudden disruptions.</a:t>
-            </a:r>
-            <a:endParaRPr lang="en-US" sz="1200" dirty="0"/>
+              <a:t>Why cloud IDEs and existing ecosystem continuity tools leave developers stranded during sudden disruptions.</a:t>
+            </a:r>
+            <a:endParaRPr lang="en-US" sz="1150" dirty="0"/>
           </a:p>
         </p:txBody>
       </p:sp>
@@ -1986,8 +1986,8 @@
         </p:nvSpPr>
         <p:spPr>
           <a:xfrm>
-            <a:off x="731520" y="6400800"/>
-            <a:ext cx="9144000" cy="274320"/>
+            <a:off x="731520" y="6355080"/>
+            <a:ext cx="10725912" cy="228600"/>
           </a:xfrm>
           <a:prstGeom prst="rect">
             <a:avLst/>
@@ -2025,12 +2025,12 @@
         </p:nvSpPr>
         <p:spPr>
           <a:xfrm>
-            <a:off x="731520" y="1737360"/>
-            <a:ext cx="3383280" cy="4206240"/>
+            <a:off x="731520" y="1691640"/>
+            <a:ext cx="3337560" cy="4343400"/>
           </a:xfrm>
           <a:prstGeom prst="roundRect">
             <a:avLst>
-              <a:gd name="adj" fmla="val 4054"/>
+              <a:gd name="adj" fmla="val 3288"/>
             </a:avLst>
           </a:prstGeom>
           <a:solidFill>
@@ -2052,24 +2052,24 @@
         </p:nvSpPr>
         <p:spPr>
           <a:xfrm>
-            <a:off x="1005840" y="2011680"/>
-            <a:ext cx="2834640" cy="274320"/>
-          </a:xfrm>
-          <a:prstGeom prst="rect">
-            <a:avLst/>
-          </a:prstGeom>
-          <a:noFill/>
-          <a:ln/>
-        </p:spPr>
-        <p:txBody>
-          <a:bodyPr wrap="square" rtlCol="0" anchor="ctr"/>
-          <a:lstStyle/>
-          <a:p>
-            <a:pPr indent="0" marL="0">
-              <a:buNone/>
-            </a:pPr>
-            <a:r>
-              <a:rPr lang="en-US" sz="900" b="1" dirty="0">
+            <a:off x="1005840" y="1965960"/>
+            <a:ext cx="2788920" cy="274320"/>
+          </a:xfrm>
+          <a:prstGeom prst="rect">
+            <a:avLst/>
+          </a:prstGeom>
+          <a:noFill/>
+          <a:ln/>
+        </p:spPr>
+        <p:txBody>
+          <a:bodyPr wrap="square" rtlCol="0" anchor="ctr"/>
+          <a:lstStyle/>
+          <a:p>
+            <a:pPr indent="0" marL="0">
+              <a:buNone/>
+            </a:pPr>
+            <a:r>
+              <a:rPr lang="en-US" sz="950" b="1" dirty="0">
                 <a:solidFill>
                   <a:srgbClr val="EF4444"/>
                 </a:solidFill>
@@ -2079,7 +2079,7 @@
               </a:rPr>
               <a:t>CONTEXT WIPEOUT</a:t>
             </a:r>
-            <a:endParaRPr lang="en-US" sz="900" dirty="0"/>
+            <a:endParaRPr lang="en-US" sz="950" dirty="0"/>
           </a:p>
         </p:txBody>
       </p:sp>
@@ -2091,8 +2091,8 @@
         </p:nvSpPr>
         <p:spPr>
           <a:xfrm>
-            <a:off x="1005840" y="2377440"/>
-            <a:ext cx="2834640" cy="640080"/>
+            <a:off x="1005840" y="2331720"/>
+            <a:ext cx="2788920" cy="594360"/>
           </a:xfrm>
           <a:prstGeom prst="rect">
             <a:avLst/>
@@ -2116,7 +2116,7 @@
                 <a:ea typeface="Arial" pitchFamily="34" charset="-122"/>
                 <a:cs typeface="Arial" pitchFamily="34" charset="-120"/>
               </a:rPr>
-              <a:t>🚨 Sudden Laptop Crash / Battery Death</a:t>
+              <a:t>🚨 Sudden Crash / Power Death</a:t>
             </a:r>
             <a:endParaRPr lang="en-US" sz="1400" dirty="0"/>
           </a:p>
@@ -2130,8 +2130,8 @@
         </p:nvSpPr>
         <p:spPr>
           <a:xfrm>
-            <a:off x="1005840" y="3108960"/>
-            <a:ext cx="2834640" cy="2560320"/>
+            <a:off x="1005840" y="3063240"/>
+            <a:ext cx="2788920" cy="2743200"/>
           </a:xfrm>
           <a:prstGeom prst="rect">
             <a:avLst/>
@@ -2172,12 +2172,12 @@
         </p:nvSpPr>
         <p:spPr>
           <a:xfrm>
-            <a:off x="4297680" y="1737360"/>
-            <a:ext cx="3383280" cy="4206240"/>
+            <a:off x="4425696" y="1691640"/>
+            <a:ext cx="3337560" cy="4343400"/>
           </a:xfrm>
           <a:prstGeom prst="roundRect">
             <a:avLst>
-              <a:gd name="adj" fmla="val 4054"/>
+              <a:gd name="adj" fmla="val 3288"/>
             </a:avLst>
           </a:prstGeom>
           <a:solidFill>
@@ -2199,24 +2199,24 @@
         </p:nvSpPr>
         <p:spPr>
           <a:xfrm>
-            <a:off x="4572000" y="2011680"/>
-            <a:ext cx="2834640" cy="274320"/>
-          </a:xfrm>
-          <a:prstGeom prst="rect">
-            <a:avLst/>
-          </a:prstGeom>
-          <a:noFill/>
-          <a:ln/>
-        </p:spPr>
-        <p:txBody>
-          <a:bodyPr wrap="square" rtlCol="0" anchor="ctr"/>
-          <a:lstStyle/>
-          <a:p>
-            <a:pPr indent="0" marL="0">
-              <a:buNone/>
-            </a:pPr>
-            <a:r>
-              <a:rPr lang="en-US" sz="900" b="1" dirty="0">
+            <a:off x="4700016" y="1965960"/>
+            <a:ext cx="2788920" cy="274320"/>
+          </a:xfrm>
+          <a:prstGeom prst="rect">
+            <a:avLst/>
+          </a:prstGeom>
+          <a:noFill/>
+          <a:ln/>
+        </p:spPr>
+        <p:txBody>
+          <a:bodyPr wrap="square" rtlCol="0" anchor="ctr"/>
+          <a:lstStyle/>
+          <a:p>
+            <a:pPr indent="0" marL="0">
+              <a:buNone/>
+            </a:pPr>
+            <a:r>
+              <a:rPr lang="en-US" sz="950" b="1" dirty="0">
                 <a:solidFill>
                   <a:srgbClr val="F59E0B"/>
                 </a:solidFill>
@@ -2226,7 +2226,7 @@
               </a:rPr>
               <a:t>ZERO RESILIENCE</a:t>
             </a:r>
-            <a:endParaRPr lang="en-US" sz="900" dirty="0"/>
+            <a:endParaRPr lang="en-US" sz="950" dirty="0"/>
           </a:p>
         </p:txBody>
       </p:sp>
@@ -2238,8 +2238,8 @@
         </p:nvSpPr>
         <p:spPr>
           <a:xfrm>
-            <a:off x="4572000" y="2377440"/>
-            <a:ext cx="2834640" cy="640080"/>
+            <a:off x="4700016" y="2331720"/>
+            <a:ext cx="2788920" cy="594360"/>
           </a:xfrm>
           <a:prstGeom prst="rect">
             <a:avLst/>
@@ -2263,7 +2263,7 @@
                 <a:ea typeface="Arial" pitchFamily="34" charset="-122"/>
                 <a:cs typeface="Arial" pitchFamily="34" charset="-120"/>
               </a:rPr>
-              <a:t>☁️ Cloud IDEs Require 100% Internet</a:t>
+              <a:t>☁️ Cloud IDEs Need 100% Internet</a:t>
             </a:r>
             <a:endParaRPr lang="en-US" sz="1400" dirty="0"/>
           </a:p>
@@ -2277,8 +2277,8 @@
         </p:nvSpPr>
         <p:spPr>
           <a:xfrm>
-            <a:off x="4572000" y="3108960"/>
-            <a:ext cx="2834640" cy="2560320"/>
+            <a:off x="4700016" y="3063240"/>
+            <a:ext cx="2788920" cy="2743200"/>
           </a:xfrm>
           <a:prstGeom prst="rect">
             <a:avLst/>
@@ -2305,7 +2305,7 @@
                 <a:ea typeface="Arial" pitchFamily="34" charset="-122"/>
                 <a:cs typeface="Arial" pitchFamily="34" charset="-120"/>
               </a:rPr>
-              <a:t>Cloud environments (Codespaces) immediately sever and freeze without active Wi-Fi, leaving field engineers and travelers stranded with zero access.</a:t>
+              <a:t>Cloud environments (Codespaces) immediately sever and freeze without active Wi-Fi, leaving field engineers stranded with zero offline access.</a:t>
             </a:r>
             <a:endParaRPr lang="en-US" sz="1100" dirty="0"/>
           </a:p>
@@ -2319,12 +2319,12 @@
         </p:nvSpPr>
         <p:spPr>
           <a:xfrm>
-            <a:off x="7863840" y="1737360"/>
-            <a:ext cx="3383280" cy="4206240"/>
+            <a:off x="8119872" y="1691640"/>
+            <a:ext cx="3337560" cy="4343400"/>
           </a:xfrm>
           <a:prstGeom prst="roundRect">
             <a:avLst>
-              <a:gd name="adj" fmla="val 4054"/>
+              <a:gd name="adj" fmla="val 3288"/>
             </a:avLst>
           </a:prstGeom>
           <a:solidFill>
@@ -2346,24 +2346,24 @@
         </p:nvSpPr>
         <p:spPr>
           <a:xfrm>
-            <a:off x="8138160" y="2011680"/>
-            <a:ext cx="2834640" cy="274320"/>
-          </a:xfrm>
-          <a:prstGeom prst="rect">
-            <a:avLst/>
-          </a:prstGeom>
-          <a:noFill/>
-          <a:ln/>
-        </p:spPr>
-        <p:txBody>
-          <a:bodyPr wrap="square" rtlCol="0" anchor="ctr"/>
-          <a:lstStyle/>
-          <a:p>
-            <a:pPr indent="0" marL="0">
-              <a:buNone/>
-            </a:pPr>
-            <a:r>
-              <a:rPr lang="en-US" sz="900" b="1" dirty="0">
+            <a:off x="8394192" y="1965960"/>
+            <a:ext cx="2788920" cy="274320"/>
+          </a:xfrm>
+          <a:prstGeom prst="rect">
+            <a:avLst/>
+          </a:prstGeom>
+          <a:noFill/>
+          <a:ln/>
+        </p:spPr>
+        <p:txBody>
+          <a:bodyPr wrap="square" rtlCol="0" anchor="ctr"/>
+          <a:lstStyle/>
+          <a:p>
+            <a:pPr indent="0" marL="0">
+              <a:buNone/>
+            </a:pPr>
+            <a:r>
+              <a:rPr lang="en-US" sz="950" b="1" dirty="0">
                 <a:solidFill>
                   <a:srgbClr val="8B5CF6"/>
                 </a:solidFill>
@@ -2373,7 +2373,7 @@
               </a:rPr>
               <a:t>MERGE CONFLICTS</a:t>
             </a:r>
-            <a:endParaRPr lang="en-US" sz="900" dirty="0"/>
+            <a:endParaRPr lang="en-US" sz="950" dirty="0"/>
           </a:p>
         </p:txBody>
       </p:sp>
@@ -2385,8 +2385,8 @@
         </p:nvSpPr>
         <p:spPr>
           <a:xfrm>
-            <a:off x="8138160" y="2377440"/>
-            <a:ext cx="2834640" cy="640080"/>
+            <a:off x="8394192" y="2331720"/>
+            <a:ext cx="2788920" cy="594360"/>
           </a:xfrm>
           <a:prstGeom prst="rect">
             <a:avLst/>
@@ -2410,7 +2410,7 @@
                 <a:ea typeface="Arial" pitchFamily="34" charset="-122"/>
                 <a:cs typeface="Arial" pitchFamily="34" charset="-120"/>
               </a:rPr>
-              <a:t>🔀 Painful Reconnection &amp; File Conflicts</a:t>
+              <a:t>🔀 Painful Reconnection Overwrites</a:t>
             </a:r>
             <a:endParaRPr lang="en-US" sz="1400" dirty="0"/>
           </a:p>
@@ -2424,8 +2424,8 @@
         </p:nvSpPr>
         <p:spPr>
           <a:xfrm>
-            <a:off x="8138160" y="3108960"/>
-            <a:ext cx="2834640" cy="2560320"/>
+            <a:off x="8394192" y="3063240"/>
+            <a:ext cx="2788920" cy="2743200"/>
           </a:xfrm>
           <a:prstGeom prst="rect">
             <a:avLst/>
@@ -2452,7 +2452,7 @@
                 <a:ea typeface="Arial" pitchFamily="34" charset="-122"/>
                 <a:cs typeface="Arial" pitchFamily="34" charset="-120"/>
               </a:rPr>
-              <a:t>Rewriting work from memory after reboot causes duplicate code, messy file overwrites, and painful Git branch conflicts.</a:t>
+              <a:t>Rewriting work from memory after reboot causes duplicate code, messy file overwrites, and painful Git branch merge conflicts.</a:t>
             </a:r>
             <a:endParaRPr lang="en-US" sz="1100" dirty="0"/>
           </a:p>
@@ -2499,7 +2499,7 @@
         <p:spPr>
           <a:xfrm>
             <a:off x="731520" y="365760"/>
-            <a:ext cx="7315200" cy="274320"/>
+            <a:ext cx="7315200" cy="228600"/>
           </a:xfrm>
           <a:prstGeom prst="rect">
             <a:avLst/>
@@ -2538,7 +2538,7 @@
         <p:spPr>
           <a:xfrm>
             <a:off x="731520" y="594360"/>
-            <a:ext cx="10515600" cy="548640"/>
+            <a:ext cx="10725912" cy="502920"/>
           </a:xfrm>
           <a:prstGeom prst="rect">
             <a:avLst/>
@@ -2576,24 +2576,24 @@
         </p:nvSpPr>
         <p:spPr>
           <a:xfrm>
-            <a:off x="731520" y="1143000"/>
-            <a:ext cx="10515600" cy="320040"/>
-          </a:xfrm>
-          <a:prstGeom prst="rect">
-            <a:avLst/>
-          </a:prstGeom>
-          <a:noFill/>
-          <a:ln/>
-        </p:spPr>
-        <p:txBody>
-          <a:bodyPr wrap="square" rtlCol="0" anchor="ctr"/>
-          <a:lstStyle/>
-          <a:p>
-            <a:pPr indent="0" marL="0">
-              <a:buNone/>
-            </a:pPr>
-            <a:r>
-              <a:rPr lang="en-US" sz="1200" dirty="0">
+            <a:off x="731520" y="1115568"/>
+            <a:ext cx="10725912" cy="320040"/>
+          </a:xfrm>
+          <a:prstGeom prst="rect">
+            <a:avLst/>
+          </a:prstGeom>
+          <a:noFill/>
+          <a:ln/>
+        </p:spPr>
+        <p:txBody>
+          <a:bodyPr wrap="square" rtlCol="0" anchor="ctr"/>
+          <a:lstStyle/>
+          <a:p>
+            <a:pPr indent="0" marL="0">
+              <a:buNone/>
+            </a:pPr>
+            <a:r>
+              <a:rPr lang="en-US" sz="1150" dirty="0">
                 <a:solidFill>
                   <a:srgbClr val="94A3B8"/>
                 </a:solidFill>
@@ -2603,7 +2603,7 @@
               </a:rPr>
               <a:t>Open-Source SLM at the core with active smartphone loop via vivo/iQOO Office Kit Bridge.</a:t>
             </a:r>
-            <a:endParaRPr lang="en-US" sz="1200" dirty="0"/>
+            <a:endParaRPr lang="en-US" sz="1150" dirty="0"/>
           </a:p>
         </p:txBody>
       </p:sp>
@@ -2615,8 +2615,8 @@
         </p:nvSpPr>
         <p:spPr>
           <a:xfrm>
-            <a:off x="731520" y="6400800"/>
-            <a:ext cx="9144000" cy="274320"/>
+            <a:off x="731520" y="6355080"/>
+            <a:ext cx="10725912" cy="228600"/>
           </a:xfrm>
           <a:prstGeom prst="rect">
             <a:avLst/>
@@ -2654,12 +2654,12 @@
         </p:nvSpPr>
         <p:spPr>
           <a:xfrm>
-            <a:off x="731520" y="1645920"/>
-            <a:ext cx="5212080" cy="4389120"/>
+            <a:off x="731520" y="1691640"/>
+            <a:ext cx="5166360" cy="4343400"/>
           </a:xfrm>
           <a:prstGeom prst="roundRect">
             <a:avLst>
-              <a:gd name="adj" fmla="val 3125"/>
+              <a:gd name="adj" fmla="val 2526"/>
             </a:avLst>
           </a:prstGeom>
           <a:solidFill>
@@ -2681,8 +2681,8 @@
         </p:nvSpPr>
         <p:spPr>
           <a:xfrm>
-            <a:off x="1005840" y="1920240"/>
-            <a:ext cx="4663440" cy="365760"/>
+            <a:off x="1005840" y="1965960"/>
+            <a:ext cx="4617720" cy="320040"/>
           </a:xfrm>
           <a:prstGeom prst="rect">
             <a:avLst/>
@@ -2720,8 +2720,8 @@
         </p:nvSpPr>
         <p:spPr>
           <a:xfrm>
-            <a:off x="1005840" y="2377440"/>
-            <a:ext cx="4663440" cy="3383280"/>
+            <a:off x="1005840" y="2423160"/>
+            <a:ext cx="4617720" cy="3383280"/>
           </a:xfrm>
           <a:prstGeom prst="rect">
             <a:avLst/>
@@ -2828,7 +2828,7 @@
                 <a:ea typeface="Arial" pitchFamily="34" charset="-122"/>
                 <a:cs typeface="Arial" pitchFamily="34" charset="-120"/>
               </a:rPr>
-              <a:t>• Zero IP Leakage: Proprietary enterprise code never leaves device flash</a:t>
+              <a:t>• Zero IP Leakage: Proprietary enterprise code never leaves device flash storage</a:t>
             </a:r>
             <a:endParaRPr lang="en-US" sz="1100" dirty="0"/>
           </a:p>
@@ -2842,12 +2842,12 @@
         </p:nvSpPr>
         <p:spPr>
           <a:xfrm>
-            <a:off x="6217920" y="1645920"/>
-            <a:ext cx="5212080" cy="4389120"/>
+            <a:off x="6291072" y="1691640"/>
+            <a:ext cx="5166360" cy="4343400"/>
           </a:xfrm>
           <a:prstGeom prst="roundRect">
             <a:avLst>
-              <a:gd name="adj" fmla="val 3125"/>
+              <a:gd name="adj" fmla="val 2526"/>
             </a:avLst>
           </a:prstGeom>
           <a:solidFill>
@@ -2869,8 +2869,8 @@
         </p:nvSpPr>
         <p:spPr>
           <a:xfrm>
-            <a:off x="6492240" y="1920240"/>
-            <a:ext cx="4663440" cy="365760"/>
+            <a:off x="6565392" y="1965960"/>
+            <a:ext cx="4617720" cy="320040"/>
           </a:xfrm>
           <a:prstGeom prst="rect">
             <a:avLst/>
@@ -2908,8 +2908,8 @@
         </p:nvSpPr>
         <p:spPr>
           <a:xfrm>
-            <a:off x="6492240" y="2377440"/>
-            <a:ext cx="4663440" cy="3383280"/>
+            <a:off x="6565392" y="2423160"/>
+            <a:ext cx="4617720" cy="3383280"/>
           </a:xfrm>
           <a:prstGeom prst="rect">
             <a:avLst/>
@@ -2976,7 +2976,7 @@
                 <a:ea typeface="Arial" pitchFamily="34" charset="-122"/>
                 <a:cs typeface="Arial" pitchFamily="34" charset="-120"/>
               </a:rPr>
-              <a:t>• Hot-Standby Session Handover: Recovers exact cursor line &amp; terminal state within 300ms</a:t>
+              <a:t>• Hot-Standby Handover: Recovers exact cursor line &amp; terminal state within 300ms</a:t>
             </a:r>
             <a:endParaRPr lang="en-US" sz="1100" dirty="0"/>
           </a:p>
@@ -3063,7 +3063,7 @@
         <p:spPr>
           <a:xfrm>
             <a:off x="731520" y="365760"/>
-            <a:ext cx="7315200" cy="274320"/>
+            <a:ext cx="7315200" cy="228600"/>
           </a:xfrm>
           <a:prstGeom prst="rect">
             <a:avLst/>
@@ -3102,7 +3102,7 @@
         <p:spPr>
           <a:xfrm>
             <a:off x="731520" y="594360"/>
-            <a:ext cx="10515600" cy="548640"/>
+            <a:ext cx="10725912" cy="502920"/>
           </a:xfrm>
           <a:prstGeom prst="rect">
             <a:avLst/>
@@ -3140,24 +3140,24 @@
         </p:nvSpPr>
         <p:spPr>
           <a:xfrm>
-            <a:off x="731520" y="1143000"/>
-            <a:ext cx="10515600" cy="320040"/>
-          </a:xfrm>
-          <a:prstGeom prst="rect">
-            <a:avLst/>
-          </a:prstGeom>
-          <a:noFill/>
-          <a:ln/>
-        </p:spPr>
-        <p:txBody>
-          <a:bodyPr wrap="square" rtlCol="0" anchor="ctr"/>
-          <a:lstStyle/>
-          <a:p>
-            <a:pPr indent="0" marL="0">
-              <a:buNone/>
-            </a:pPr>
-            <a:r>
-              <a:rPr lang="en-US" sz="1200" dirty="0">
+            <a:off x="731520" y="1115568"/>
+            <a:ext cx="10725912" cy="320040"/>
+          </a:xfrm>
+          <a:prstGeom prst="rect">
+            <a:avLst/>
+          </a:prstGeom>
+          <a:noFill/>
+          <a:ln/>
+        </p:spPr>
+        <p:txBody>
+          <a:bodyPr wrap="square" rtlCol="0" anchor="ctr"/>
+          <a:lstStyle/>
+          <a:p>
+            <a:pPr indent="0" marL="0">
+              <a:buNone/>
+            </a:pPr>
+            <a:r>
+              <a:rPr lang="en-US" sz="1150" dirty="0">
                 <a:solidFill>
                   <a:srgbClr val="94A3B8"/>
                 </a:solidFill>
@@ -3167,7 +3167,7 @@
               </a:rPr>
               <a:t>Engineered for maximum resilience, tactile feedback, and enterprise security.</a:t>
             </a:r>
-            <a:endParaRPr lang="en-US" sz="1200" dirty="0"/>
+            <a:endParaRPr lang="en-US" sz="1150" dirty="0"/>
           </a:p>
         </p:txBody>
       </p:sp>
@@ -3179,8 +3179,8 @@
         </p:nvSpPr>
         <p:spPr>
           <a:xfrm>
-            <a:off x="731520" y="6400800"/>
-            <a:ext cx="9144000" cy="274320"/>
+            <a:off x="731520" y="6355080"/>
+            <a:ext cx="10725912" cy="228600"/>
           </a:xfrm>
           <a:prstGeom prst="rect">
             <a:avLst/>
@@ -3218,12 +3218,12 @@
         </p:nvSpPr>
         <p:spPr>
           <a:xfrm>
-            <a:off x="731520" y="1737360"/>
-            <a:ext cx="5120640" cy="1920240"/>
+            <a:off x="731520" y="1691640"/>
+            <a:ext cx="5166360" cy="2057400"/>
           </a:xfrm>
           <a:prstGeom prst="roundRect">
             <a:avLst>
-              <a:gd name="adj" fmla="val 5714"/>
+              <a:gd name="adj" fmla="val 5333"/>
             </a:avLst>
           </a:prstGeom>
           <a:solidFill>
@@ -3231,7 +3231,7 @@
           </a:solidFill>
           <a:ln w="12700">
             <a:solidFill>
-              <a:srgbClr val="242B3E"/>
+              <a:srgbClr val="22283A"/>
             </a:solidFill>
             <a:prstDash val="solid"/>
           </a:ln>
@@ -3245,8 +3245,8 @@
         </p:nvSpPr>
         <p:spPr>
           <a:xfrm>
-            <a:off x="1005840" y="1965960"/>
-            <a:ext cx="2926080" cy="320040"/>
+            <a:off x="1005840" y="1920240"/>
+            <a:ext cx="3017520" cy="320040"/>
           </a:xfrm>
           <a:prstGeom prst="rect">
             <a:avLst/>
@@ -3284,8 +3284,8 @@
         </p:nvSpPr>
         <p:spPr>
           <a:xfrm>
-            <a:off x="4023360" y="1965960"/>
-            <a:ext cx="1554480" cy="320040"/>
+            <a:off x="4023360" y="1920240"/>
+            <a:ext cx="1600200" cy="320040"/>
           </a:xfrm>
           <a:prstGeom prst="rect">
             <a:avLst/>
@@ -3301,7 +3301,7 @@
               <a:buNone/>
             </a:pPr>
             <a:r>
-              <a:rPr lang="en-US" sz="900" b="1" dirty="0">
+              <a:rPr lang="en-US" sz="950" b="1" dirty="0">
                 <a:solidFill>
                   <a:srgbClr val="94A3B8"/>
                 </a:solidFill>
@@ -3311,7 +3311,7 @@
               </a:rPr>
               <a:t>&lt;300ms Handover</a:t>
             </a:r>
-            <a:endParaRPr lang="en-US" sz="900" dirty="0"/>
+            <a:endParaRPr lang="en-US" sz="950" dirty="0"/>
           </a:p>
         </p:txBody>
       </p:sp>
@@ -3323,8 +3323,8 @@
         </p:nvSpPr>
         <p:spPr>
           <a:xfrm>
-            <a:off x="1005840" y="2377440"/>
-            <a:ext cx="4572000" cy="1097280"/>
+            <a:off x="1005840" y="2331720"/>
+            <a:ext cx="4617720" cy="1234440"/>
           </a:xfrm>
           <a:prstGeom prst="rect">
             <a:avLst/>
@@ -3338,7 +3338,7 @@
           <a:p>
             <a:pPr indent="0" marL="0">
               <a:lnSpc>
-                <a:spcPts val="1600"/>
+                <a:spcPts val="1700"/>
               </a:lnSpc>
               <a:buNone/>
             </a:pPr>
@@ -3365,12 +3365,12 @@
         </p:nvSpPr>
         <p:spPr>
           <a:xfrm>
-            <a:off x="6126480" y="1737360"/>
-            <a:ext cx="5120640" cy="1920240"/>
+            <a:off x="6291072" y="1691640"/>
+            <a:ext cx="5166360" cy="2057400"/>
           </a:xfrm>
           <a:prstGeom prst="roundRect">
             <a:avLst>
-              <a:gd name="adj" fmla="val 5714"/>
+              <a:gd name="adj" fmla="val 5333"/>
             </a:avLst>
           </a:prstGeom>
           <a:solidFill>
@@ -3378,7 +3378,7 @@
           </a:solidFill>
           <a:ln w="12700">
             <a:solidFill>
-              <a:srgbClr val="242B3E"/>
+              <a:srgbClr val="22283A"/>
             </a:solidFill>
             <a:prstDash val="solid"/>
           </a:ln>
@@ -3392,8 +3392,8 @@
         </p:nvSpPr>
         <p:spPr>
           <a:xfrm>
-            <a:off x="6400800" y="1965960"/>
-            <a:ext cx="2926080" cy="320040"/>
+            <a:off x="6565392" y="1920240"/>
+            <a:ext cx="3017520" cy="320040"/>
           </a:xfrm>
           <a:prstGeom prst="rect">
             <a:avLst/>
@@ -3431,8 +3431,8 @@
         </p:nvSpPr>
         <p:spPr>
           <a:xfrm>
-            <a:off x="9418320" y="1965960"/>
-            <a:ext cx="1554480" cy="320040"/>
+            <a:off x="9582912" y="1920240"/>
+            <a:ext cx="1600200" cy="320040"/>
           </a:xfrm>
           <a:prstGeom prst="rect">
             <a:avLst/>
@@ -3448,7 +3448,7 @@
               <a:buNone/>
             </a:pPr>
             <a:r>
-              <a:rPr lang="en-US" sz="900" b="1" dirty="0">
+              <a:rPr lang="en-US" sz="950" b="1" dirty="0">
                 <a:solidFill>
                   <a:srgbClr val="94A3B8"/>
                 </a:solidFill>
@@ -3458,7 +3458,7 @@
               </a:rPr>
               <a:t>In-App Mobile Editor</a:t>
             </a:r>
-            <a:endParaRPr lang="en-US" sz="900" dirty="0"/>
+            <a:endParaRPr lang="en-US" sz="950" dirty="0"/>
           </a:p>
         </p:txBody>
       </p:sp>
@@ -3470,8 +3470,8 @@
         </p:nvSpPr>
         <p:spPr>
           <a:xfrm>
-            <a:off x="6400800" y="2377440"/>
-            <a:ext cx="4572000" cy="1097280"/>
+            <a:off x="6565392" y="2331720"/>
+            <a:ext cx="4617720" cy="1234440"/>
           </a:xfrm>
           <a:prstGeom prst="rect">
             <a:avLst/>
@@ -3485,7 +3485,7 @@
           <a:p>
             <a:pPr indent="0" marL="0">
               <a:lnSpc>
-                <a:spcPts val="1600"/>
+                <a:spcPts val="1700"/>
               </a:lnSpc>
               <a:buNone/>
             </a:pPr>
@@ -3512,12 +3512,12 @@
         </p:nvSpPr>
         <p:spPr>
           <a:xfrm>
-            <a:off x="731520" y="3931920"/>
-            <a:ext cx="5120640" cy="1920240"/>
+            <a:off x="731520" y="3977640"/>
+            <a:ext cx="5166360" cy="2057400"/>
           </a:xfrm>
           <a:prstGeom prst="roundRect">
             <a:avLst>
-              <a:gd name="adj" fmla="val 5714"/>
+              <a:gd name="adj" fmla="val 5333"/>
             </a:avLst>
           </a:prstGeom>
           <a:solidFill>
@@ -3525,7 +3525,7 @@
           </a:solidFill>
           <a:ln w="12700">
             <a:solidFill>
-              <a:srgbClr val="242B3E"/>
+              <a:srgbClr val="22283A"/>
             </a:solidFill>
             <a:prstDash val="solid"/>
           </a:ln>
@@ -3539,8 +3539,8 @@
         </p:nvSpPr>
         <p:spPr>
           <a:xfrm>
-            <a:off x="1005840" y="4160520"/>
-            <a:ext cx="2926080" cy="320040"/>
+            <a:off x="1005840" y="4206240"/>
+            <a:ext cx="3017520" cy="320040"/>
           </a:xfrm>
           <a:prstGeom prst="rect">
             <a:avLst/>
@@ -3578,8 +3578,8 @@
         </p:nvSpPr>
         <p:spPr>
           <a:xfrm>
-            <a:off x="4023360" y="4160520"/>
-            <a:ext cx="1554480" cy="320040"/>
+            <a:off x="4023360" y="4206240"/>
+            <a:ext cx="1600200" cy="320040"/>
           </a:xfrm>
           <a:prstGeom prst="rect">
             <a:avLst/>
@@ -3595,7 +3595,7 @@
               <a:buNone/>
             </a:pPr>
             <a:r>
-              <a:rPr lang="en-US" sz="900" b="1" dirty="0">
+              <a:rPr lang="en-US" sz="950" b="1" dirty="0">
                 <a:solidFill>
                   <a:srgbClr val="94A3B8"/>
                 </a:solidFill>
@@ -3605,7 +3605,7 @@
               </a:rPr>
               <a:t>Qwen 2.5-Coder 1.5B</a:t>
             </a:r>
-            <a:endParaRPr lang="en-US" sz="900" dirty="0"/>
+            <a:endParaRPr lang="en-US" sz="950" dirty="0"/>
           </a:p>
         </p:txBody>
       </p:sp>
@@ -3617,8 +3617,8 @@
         </p:nvSpPr>
         <p:spPr>
           <a:xfrm>
-            <a:off x="1005840" y="4572000"/>
-            <a:ext cx="4572000" cy="1097280"/>
+            <a:off x="1005840" y="4617720"/>
+            <a:ext cx="4617720" cy="1234440"/>
           </a:xfrm>
           <a:prstGeom prst="rect">
             <a:avLst/>
@@ -3632,7 +3632,7 @@
           <a:p>
             <a:pPr indent="0" marL="0">
               <a:lnSpc>
-                <a:spcPts val="1600"/>
+                <a:spcPts val="1700"/>
               </a:lnSpc>
               <a:buNone/>
             </a:pPr>
@@ -3659,12 +3659,12 @@
         </p:nvSpPr>
         <p:spPr>
           <a:xfrm>
-            <a:off x="6126480" y="3931920"/>
-            <a:ext cx="5120640" cy="1920240"/>
+            <a:off x="6291072" y="3977640"/>
+            <a:ext cx="5166360" cy="2057400"/>
           </a:xfrm>
           <a:prstGeom prst="roundRect">
             <a:avLst>
-              <a:gd name="adj" fmla="val 5714"/>
+              <a:gd name="adj" fmla="val 5333"/>
             </a:avLst>
           </a:prstGeom>
           <a:solidFill>
@@ -3672,7 +3672,7 @@
           </a:solidFill>
           <a:ln w="12700">
             <a:solidFill>
-              <a:srgbClr val="242B3E"/>
+              <a:srgbClr val="22283A"/>
             </a:solidFill>
             <a:prstDash val="solid"/>
           </a:ln>
@@ -3686,8 +3686,8 @@
         </p:nvSpPr>
         <p:spPr>
           <a:xfrm>
-            <a:off x="6400800" y="4160520"/>
-            <a:ext cx="2926080" cy="320040"/>
+            <a:off x="6565392" y="4206240"/>
+            <a:ext cx="3017520" cy="320040"/>
           </a:xfrm>
           <a:prstGeom prst="rect">
             <a:avLst/>
@@ -3725,8 +3725,8 @@
         </p:nvSpPr>
         <p:spPr>
           <a:xfrm>
-            <a:off x="9418320" y="4160520"/>
-            <a:ext cx="1554480" cy="320040"/>
+            <a:off x="9582912" y="4206240"/>
+            <a:ext cx="1600200" cy="320040"/>
           </a:xfrm>
           <a:prstGeom prst="rect">
             <a:avLst/>
@@ -3742,7 +3742,7 @@
               <a:buNone/>
             </a:pPr>
             <a:r>
-              <a:rPr lang="en-US" sz="900" b="1" dirty="0">
+              <a:rPr lang="en-US" sz="950" b="1" dirty="0">
                 <a:solidFill>
                   <a:srgbClr val="94A3B8"/>
                 </a:solidFill>
@@ -3752,7 +3752,7 @@
               </a:rPr>
               <a:t>3-Way Merge Inspector</a:t>
             </a:r>
-            <a:endParaRPr lang="en-US" sz="900" dirty="0"/>
+            <a:endParaRPr lang="en-US" sz="950" dirty="0"/>
           </a:p>
         </p:txBody>
       </p:sp>
@@ -3764,8 +3764,8 @@
         </p:nvSpPr>
         <p:spPr>
           <a:xfrm>
-            <a:off x="6400800" y="4572000"/>
-            <a:ext cx="4572000" cy="1097280"/>
+            <a:off x="6565392" y="4617720"/>
+            <a:ext cx="4617720" cy="1234440"/>
           </a:xfrm>
           <a:prstGeom prst="rect">
             <a:avLst/>
@@ -3779,7 +3779,7 @@
           <a:p>
             <a:pPr indent="0" marL="0">
               <a:lnSpc>
-                <a:spcPts val="1600"/>
+                <a:spcPts val="1700"/>
               </a:lnSpc>
               <a:buNone/>
             </a:pPr>
@@ -3839,7 +3839,7 @@
         <p:spPr>
           <a:xfrm>
             <a:off x="731520" y="365760"/>
-            <a:ext cx="7315200" cy="274320"/>
+            <a:ext cx="7315200" cy="228600"/>
           </a:xfrm>
           <a:prstGeom prst="rect">
             <a:avLst/>
@@ -3878,7 +3878,7 @@
         <p:spPr>
           <a:xfrm>
             <a:off x="731520" y="594360"/>
-            <a:ext cx="10515600" cy="548640"/>
+            <a:ext cx="10725912" cy="502920"/>
           </a:xfrm>
           <a:prstGeom prst="rect">
             <a:avLst/>
@@ -3916,24 +3916,24 @@
         </p:nvSpPr>
         <p:spPr>
           <a:xfrm>
-            <a:off x="731520" y="1143000"/>
-            <a:ext cx="10515600" cy="320040"/>
-          </a:xfrm>
-          <a:prstGeom prst="rect">
-            <a:avLst/>
-          </a:prstGeom>
-          <a:noFill/>
-          <a:ln/>
-        </p:spPr>
-        <p:txBody>
-          <a:bodyPr wrap="square" rtlCol="0" anchor="ctr"/>
-          <a:lstStyle/>
-          <a:p>
-            <a:pPr indent="0" marL="0">
-              <a:buNone/>
-            </a:pPr>
-            <a:r>
-              <a:rPr lang="en-US" sz="1200" dirty="0">
+            <a:off x="731520" y="1115568"/>
+            <a:ext cx="10725912" cy="320040"/>
+          </a:xfrm>
+          <a:prstGeom prst="rect">
+            <a:avLst/>
+          </a:prstGeom>
+          <a:noFill/>
+          <a:ln/>
+        </p:spPr>
+        <p:txBody>
+          <a:bodyPr wrap="square" rtlCol="0" anchor="ctr"/>
+          <a:lstStyle/>
+          <a:p>
+            <a:pPr indent="0" marL="0">
+              <a:buNone/>
+            </a:pPr>
+            <a:r>
+              <a:rPr lang="en-US" sz="1150" dirty="0">
                 <a:solidFill>
                   <a:srgbClr val="94A3B8"/>
                 </a:solidFill>
@@ -3943,7 +3943,7 @@
               </a:rPr>
               <a:t>Demonstrated via our built-in 1-Click 4-Stage Demo Controller with synthetic acoustic and haptic cues.</a:t>
             </a:r>
-            <a:endParaRPr lang="en-US" sz="1200" dirty="0"/>
+            <a:endParaRPr lang="en-US" sz="1150" dirty="0"/>
           </a:p>
         </p:txBody>
       </p:sp>
@@ -3955,8 +3955,8 @@
         </p:nvSpPr>
         <p:spPr>
           <a:xfrm>
-            <a:off x="731520" y="6400800"/>
-            <a:ext cx="9144000" cy="274320"/>
+            <a:off x="731520" y="6355080"/>
+            <a:ext cx="10725912" cy="228600"/>
           </a:xfrm>
           <a:prstGeom prst="rect">
             <a:avLst/>
@@ -3994,12 +3994,12 @@
         </p:nvSpPr>
         <p:spPr>
           <a:xfrm>
-            <a:off x="731520" y="1737360"/>
-            <a:ext cx="2514600" cy="4206240"/>
+            <a:off x="731520" y="1691640"/>
+            <a:ext cx="2468880" cy="4343400"/>
           </a:xfrm>
           <a:prstGeom prst="roundRect">
             <a:avLst>
-              <a:gd name="adj" fmla="val 4364"/>
+              <a:gd name="adj" fmla="val 4444"/>
             </a:avLst>
           </a:prstGeom>
           <a:solidFill>
@@ -4007,7 +4007,7 @@
           </a:solidFill>
           <a:ln w="19050">
             <a:solidFill>
-              <a:srgbClr val="2A314A"/>
+              <a:srgbClr val="22283A"/>
             </a:solidFill>
             <a:prstDash val="solid"/>
           </a:ln>
@@ -4021,8 +4021,8 @@
         </p:nvSpPr>
         <p:spPr>
           <a:xfrm>
-            <a:off x="914400" y="2011680"/>
-            <a:ext cx="2148840" cy="274320"/>
+            <a:off x="914400" y="1965960"/>
+            <a:ext cx="2103120" cy="274320"/>
           </a:xfrm>
           <a:prstGeom prst="rect">
             <a:avLst/>
@@ -4060,8 +4060,8 @@
         </p:nvSpPr>
         <p:spPr>
           <a:xfrm>
-            <a:off x="914400" y="2377440"/>
-            <a:ext cx="2148840" cy="548640"/>
+            <a:off x="914400" y="2331720"/>
+            <a:ext cx="2103120" cy="594360"/>
           </a:xfrm>
           <a:prstGeom prst="rect">
             <a:avLst/>
@@ -4100,7 +4100,7 @@
         <p:spPr>
           <a:xfrm>
             <a:off x="914400" y="3017520"/>
-            <a:ext cx="2148840" cy="2560320"/>
+            <a:ext cx="2103120" cy="2743200"/>
           </a:xfrm>
           <a:prstGeom prst="rect">
             <a:avLst/>
@@ -4141,12 +4141,12 @@
         </p:nvSpPr>
         <p:spPr>
           <a:xfrm>
-            <a:off x="3429000" y="1737360"/>
-            <a:ext cx="2514600" cy="4206240"/>
+            <a:off x="3483864" y="1691640"/>
+            <a:ext cx="2468880" cy="4343400"/>
           </a:xfrm>
           <a:prstGeom prst="roundRect">
             <a:avLst>
-              <a:gd name="adj" fmla="val 4364"/>
+              <a:gd name="adj" fmla="val 4444"/>
             </a:avLst>
           </a:prstGeom>
           <a:solidFill>
@@ -4168,8 +4168,8 @@
         </p:nvSpPr>
         <p:spPr>
           <a:xfrm>
-            <a:off x="3611880" y="2011680"/>
-            <a:ext cx="2148840" cy="274320"/>
+            <a:off x="3666744" y="1965960"/>
+            <a:ext cx="2103120" cy="274320"/>
           </a:xfrm>
           <a:prstGeom prst="rect">
             <a:avLst/>
@@ -4207,8 +4207,8 @@
         </p:nvSpPr>
         <p:spPr>
           <a:xfrm>
-            <a:off x="3611880" y="2377440"/>
-            <a:ext cx="2148840" cy="548640"/>
+            <a:off x="3666744" y="2331720"/>
+            <a:ext cx="2103120" cy="594360"/>
           </a:xfrm>
           <a:prstGeom prst="rect">
             <a:avLst/>
@@ -4246,8 +4246,8 @@
         </p:nvSpPr>
         <p:spPr>
           <a:xfrm>
-            <a:off x="3611880" y="3017520"/>
-            <a:ext cx="2148840" cy="2560320"/>
+            <a:off x="3666744" y="3017520"/>
+            <a:ext cx="2103120" cy="2743200"/>
           </a:xfrm>
           <a:prstGeom prst="rect">
             <a:avLst/>
@@ -4288,12 +4288,12 @@
         </p:nvSpPr>
         <p:spPr>
           <a:xfrm>
-            <a:off x="6126480" y="1737360"/>
-            <a:ext cx="2514600" cy="4206240"/>
+            <a:off x="6236208" y="1691640"/>
+            <a:ext cx="2468880" cy="4343400"/>
           </a:xfrm>
           <a:prstGeom prst="roundRect">
             <a:avLst>
-              <a:gd name="adj" fmla="val 4364"/>
+              <a:gd name="adj" fmla="val 4444"/>
             </a:avLst>
           </a:prstGeom>
           <a:solidFill>
@@ -4301,7 +4301,7 @@
           </a:solidFill>
           <a:ln w="19050">
             <a:solidFill>
-              <a:srgbClr val="2A314A"/>
+              <a:srgbClr val="22283A"/>
             </a:solidFill>
             <a:prstDash val="solid"/>
           </a:ln>
@@ -4315,8 +4315,8 @@
         </p:nvSpPr>
         <p:spPr>
           <a:xfrm>
-            <a:off x="6309360" y="2011680"/>
-            <a:ext cx="2148840" cy="274320"/>
+            <a:off x="6419088" y="1965960"/>
+            <a:ext cx="2103120" cy="274320"/>
           </a:xfrm>
           <a:prstGeom prst="rect">
             <a:avLst/>
@@ -4354,8 +4354,8 @@
         </p:nvSpPr>
         <p:spPr>
           <a:xfrm>
-            <a:off x="6309360" y="2377440"/>
-            <a:ext cx="2148840" cy="548640"/>
+            <a:off x="6419088" y="2331720"/>
+            <a:ext cx="2103120" cy="594360"/>
           </a:xfrm>
           <a:prstGeom prst="rect">
             <a:avLst/>
@@ -4393,8 +4393,8 @@
         </p:nvSpPr>
         <p:spPr>
           <a:xfrm>
-            <a:off x="6309360" y="3017520"/>
-            <a:ext cx="2148840" cy="2560320"/>
+            <a:off x="6419088" y="3017520"/>
+            <a:ext cx="2103120" cy="2743200"/>
           </a:xfrm>
           <a:prstGeom prst="rect">
             <a:avLst/>
@@ -4435,12 +4435,12 @@
         </p:nvSpPr>
         <p:spPr>
           <a:xfrm>
-            <a:off x="8823960" y="1737360"/>
-            <a:ext cx="2514600" cy="4206240"/>
+            <a:off x="8988552" y="1691640"/>
+            <a:ext cx="2468880" cy="4343400"/>
           </a:xfrm>
           <a:prstGeom prst="roundRect">
             <a:avLst>
-              <a:gd name="adj" fmla="val 4364"/>
+              <a:gd name="adj" fmla="val 4444"/>
             </a:avLst>
           </a:prstGeom>
           <a:solidFill>
@@ -4462,8 +4462,8 @@
         </p:nvSpPr>
         <p:spPr>
           <a:xfrm>
-            <a:off x="9006840" y="2011680"/>
-            <a:ext cx="2148840" cy="274320"/>
+            <a:off x="9171432" y="1965960"/>
+            <a:ext cx="2103120" cy="274320"/>
           </a:xfrm>
           <a:prstGeom prst="rect">
             <a:avLst/>
@@ -4501,8 +4501,8 @@
         </p:nvSpPr>
         <p:spPr>
           <a:xfrm>
-            <a:off x="9006840" y="2377440"/>
-            <a:ext cx="2148840" cy="548640"/>
+            <a:off x="9171432" y="2331720"/>
+            <a:ext cx="2103120" cy="594360"/>
           </a:xfrm>
           <a:prstGeom prst="rect">
             <a:avLst/>
@@ -4540,8 +4540,8 @@
         </p:nvSpPr>
         <p:spPr>
           <a:xfrm>
-            <a:off x="9006840" y="3017520"/>
-            <a:ext cx="2148840" cy="2560320"/>
+            <a:off x="9171432" y="3017520"/>
+            <a:ext cx="2103120" cy="2743200"/>
           </a:xfrm>
           <a:prstGeom prst="rect">
             <a:avLst/>
@@ -4615,7 +4615,7 @@
         <p:spPr>
           <a:xfrm>
             <a:off x="731520" y="365760"/>
-            <a:ext cx="7315200" cy="274320"/>
+            <a:ext cx="7315200" cy="228600"/>
           </a:xfrm>
           <a:prstGeom prst="rect">
             <a:avLst/>
@@ -4654,7 +4654,7 @@
         <p:spPr>
           <a:xfrm>
             <a:off x="731520" y="594360"/>
-            <a:ext cx="10515600" cy="548640"/>
+            <a:ext cx="10725912" cy="502920"/>
           </a:xfrm>
           <a:prstGeom prst="rect">
             <a:avLst/>
@@ -4692,24 +4692,24 @@
         </p:nvSpPr>
         <p:spPr>
           <a:xfrm>
-            <a:off x="731520" y="1143000"/>
-            <a:ext cx="10515600" cy="320040"/>
-          </a:xfrm>
-          <a:prstGeom prst="rect">
-            <a:avLst/>
-          </a:prstGeom>
-          <a:noFill/>
-          <a:ln/>
-        </p:spPr>
-        <p:txBody>
-          <a:bodyPr wrap="square" rtlCol="0" anchor="ctr"/>
-          <a:lstStyle/>
-          <a:p>
-            <a:pPr indent="0" marL="0">
-              <a:buNone/>
-            </a:pPr>
-            <a:r>
-              <a:rPr lang="en-US" sz="1200" dirty="0">
+            <a:off x="731520" y="1115568"/>
+            <a:ext cx="10725912" cy="320040"/>
+          </a:xfrm>
+          <a:prstGeom prst="rect">
+            <a:avLst/>
+          </a:prstGeom>
+          <a:noFill/>
+          <a:ln/>
+        </p:spPr>
+        <p:txBody>
+          <a:bodyPr wrap="square" rtlCol="0" anchor="ctr"/>
+          <a:lstStyle/>
+          <a:p>
+            <a:pPr indent="0" marL="0">
+              <a:buNone/>
+            </a:pPr>
+            <a:r>
+              <a:rPr lang="en-US" sz="1150" dirty="0">
                 <a:solidFill>
                   <a:srgbClr val="94A3B8"/>
                 </a:solidFill>
@@ -4719,7 +4719,7 @@
               </a:rPr>
               <a:t>Why PocketOps establishes a completely new category in cross-device resilience.</a:t>
             </a:r>
-            <a:endParaRPr lang="en-US" sz="1200" dirty="0"/>
+            <a:endParaRPr lang="en-US" sz="1150" dirty="0"/>
           </a:p>
         </p:txBody>
       </p:sp>
@@ -4731,8 +4731,8 @@
         </p:nvSpPr>
         <p:spPr>
           <a:xfrm>
-            <a:off x="731520" y="6400800"/>
-            <a:ext cx="9144000" cy="274320"/>
+            <a:off x="731520" y="6355080"/>
+            <a:ext cx="10725912" cy="228600"/>
           </a:xfrm>
           <a:prstGeom prst="rect">
             <a:avLst/>
@@ -4777,8 +4777,8 @@
           </p:nvPr>
         </p:nvGraphicFramePr>
         <p:xfrm>
-          <a:off x="731520" y="1737360"/>
-          <a:ext cx="10698480" cy="4206240"/>
+          <a:off x="731520" y="1691640"/>
+          <a:ext cx="10725912" cy="4343400"/>
         </p:xfrm>
         <a:graphic>
           <a:graphicData uri="http://schemas.openxmlformats.org/drawingml/2006/table">
@@ -4788,9 +4788,9 @@
                 <a:gridCol w="2286000"/>
                 <a:gridCol w="2651760"/>
                 <a:gridCol w="2651760"/>
-                <a:gridCol w="3108960"/>
+                <a:gridCol w="3136392"/>
               </a:tblGrid>
-              <a:tr h="701040">
+              <a:tr h="723900">
                 <a:tc>
                   <a:txBody>
                     <a:bodyPr/>
@@ -5036,7 +5036,7 @@
                   </a:tcPr>
                 </a:tc>
               </a:tr>
-              <a:tr h="701040">
+              <a:tr h="723900">
                 <a:tc>
                   <a:txBody>
                     <a:bodyPr/>
@@ -5282,7 +5282,7 @@
                   </a:tcPr>
                 </a:tc>
               </a:tr>
-              <a:tr h="701040">
+              <a:tr h="723900">
                 <a:tc>
                   <a:txBody>
                     <a:bodyPr/>
@@ -5528,7 +5528,7 @@
                   </a:tcPr>
                 </a:tc>
               </a:tr>
-              <a:tr h="701040">
+              <a:tr h="723900">
                 <a:tc>
                   <a:txBody>
                     <a:bodyPr/>
@@ -5774,7 +5774,7 @@
                   </a:tcPr>
                 </a:tc>
               </a:tr>
-              <a:tr h="701040">
+              <a:tr h="723900">
                 <a:tc>
                   <a:txBody>
                     <a:bodyPr/>
@@ -6020,7 +6020,7 @@
                   </a:tcPr>
                 </a:tc>
               </a:tr>
-              <a:tr h="701040">
+              <a:tr h="723900">
                 <a:tc>
                   <a:txBody>
                     <a:bodyPr/>
@@ -6311,7 +6311,7 @@
         <p:spPr>
           <a:xfrm>
             <a:off x="731520" y="365760"/>
-            <a:ext cx="7315200" cy="274320"/>
+            <a:ext cx="7315200" cy="228600"/>
           </a:xfrm>
           <a:prstGeom prst="rect">
             <a:avLst/>
@@ -6350,7 +6350,7 @@
         <p:spPr>
           <a:xfrm>
             <a:off x="731520" y="594360"/>
-            <a:ext cx="10515600" cy="548640"/>
+            <a:ext cx="10725912" cy="502920"/>
           </a:xfrm>
           <a:prstGeom prst="rect">
             <a:avLst/>
@@ -6388,24 +6388,24 @@
         </p:nvSpPr>
         <p:spPr>
           <a:xfrm>
-            <a:off x="731520" y="1143000"/>
-            <a:ext cx="10515600" cy="320040"/>
-          </a:xfrm>
-          <a:prstGeom prst="rect">
-            <a:avLst/>
-          </a:prstGeom>
-          <a:noFill/>
-          <a:ln/>
-        </p:spPr>
-        <p:txBody>
-          <a:bodyPr wrap="square" rtlCol="0" anchor="ctr"/>
-          <a:lstStyle/>
-          <a:p>
-            <a:pPr indent="0" marL="0">
-              <a:buNone/>
-            </a:pPr>
-            <a:r>
-              <a:rPr lang="en-US" sz="1200" dirty="0">
+            <a:off x="731520" y="1115568"/>
+            <a:ext cx="10725912" cy="320040"/>
+          </a:xfrm>
+          <a:prstGeom prst="rect">
+            <a:avLst/>
+          </a:prstGeom>
+          <a:noFill/>
+          <a:ln/>
+        </p:spPr>
+        <p:txBody>
+          <a:bodyPr wrap="square" rtlCol="0" anchor="ctr"/>
+          <a:lstStyle/>
+          <a:p>
+            <a:pPr indent="0" marL="0">
+              <a:buNone/>
+            </a:pPr>
+            <a:r>
+              <a:rPr lang="en-US" sz="1150" dirty="0">
                 <a:solidFill>
                   <a:srgbClr val="94A3B8"/>
                 </a:solidFill>
@@ -6415,7 +6415,7 @@
               </a:rPr>
               <a:t>PocketOps proves that smartphones can be active, resilient tactical enclaves for developers.</a:t>
             </a:r>
-            <a:endParaRPr lang="en-US" sz="1200" dirty="0"/>
+            <a:endParaRPr lang="en-US" sz="1150" dirty="0"/>
           </a:p>
         </p:txBody>
       </p:sp>
@@ -6427,8 +6427,8 @@
         </p:nvSpPr>
         <p:spPr>
           <a:xfrm>
-            <a:off x="731520" y="6400800"/>
-            <a:ext cx="9144000" cy="274320"/>
+            <a:off x="731520" y="6355080"/>
+            <a:ext cx="10725912" cy="228600"/>
           </a:xfrm>
           <a:prstGeom prst="rect">
             <a:avLst/>
@@ -6466,12 +6466,12 @@
         </p:nvSpPr>
         <p:spPr>
           <a:xfrm>
-            <a:off x="731520" y="1737360"/>
-            <a:ext cx="10698480" cy="4206240"/>
+            <a:off x="731520" y="1691640"/>
+            <a:ext cx="10725912" cy="4343400"/>
           </a:xfrm>
           <a:prstGeom prst="roundRect">
             <a:avLst>
-              <a:gd name="adj" fmla="val 3261"/>
+              <a:gd name="adj" fmla="val 2526"/>
             </a:avLst>
           </a:prstGeom>
           <a:solidFill>
@@ -6493,24 +6493,24 @@
         </p:nvSpPr>
         <p:spPr>
           <a:xfrm>
-            <a:off x="1097280" y="2103120"/>
-            <a:ext cx="9966960" cy="457200"/>
-          </a:xfrm>
-          <a:prstGeom prst="rect">
-            <a:avLst/>
-          </a:prstGeom>
-          <a:noFill/>
-          <a:ln/>
-        </p:spPr>
-        <p:txBody>
-          <a:bodyPr wrap="square" rtlCol="0" anchor="ctr"/>
-          <a:lstStyle/>
-          <a:p>
-            <a:pPr indent="0" marL="0">
-              <a:buNone/>
-            </a:pPr>
-            <a:r>
-              <a:rPr lang="en-US" sz="1600" b="1" dirty="0">
+            <a:off x="1097280" y="2011680"/>
+            <a:ext cx="9966960" cy="411480"/>
+          </a:xfrm>
+          <a:prstGeom prst="rect">
+            <a:avLst/>
+          </a:prstGeom>
+          <a:noFill/>
+          <a:ln/>
+        </p:spPr>
+        <p:txBody>
+          <a:bodyPr wrap="square" rtlCol="0" anchor="ctr"/>
+          <a:lstStyle/>
+          <a:p>
+            <a:pPr indent="0" marL="0">
+              <a:buNone/>
+            </a:pPr>
+            <a:r>
+              <a:rPr lang="en-US" sz="1500" b="1" dirty="0">
                 <a:solidFill>
                   <a:srgbClr val="FF5500"/>
                 </a:solidFill>
@@ -6520,7 +6520,7 @@
               </a:rPr>
               <a:t>🏆 Why PocketOps Wins the iQOO Hackathon:</a:t>
             </a:r>
-            <a:endParaRPr lang="en-US" sz="1600" dirty="0"/>
+            <a:endParaRPr lang="en-US" sz="1500" dirty="0"/>
           </a:p>
         </p:txBody>
       </p:sp>
@@ -6532,24 +6532,24 @@
         </p:nvSpPr>
         <p:spPr>
           <a:xfrm>
-            <a:off x="1097280" y="2651760"/>
-            <a:ext cx="9966960" cy="3017520"/>
-          </a:xfrm>
-          <a:prstGeom prst="rect">
-            <a:avLst/>
-          </a:prstGeom>
-          <a:noFill/>
-          <a:ln/>
-        </p:spPr>
-        <p:txBody>
-          <a:bodyPr wrap="square" rtlCol="0" anchor="ctr"/>
-          <a:lstStyle/>
-          <a:p>
-            <a:pPr indent="0" marL="0">
-              <a:buNone/>
-            </a:pPr>
-            <a:r>
-              <a:rPr lang="en-US" sz="1100" dirty="0">
+            <a:off x="1097280" y="2560320"/>
+            <a:ext cx="9966960" cy="3200400"/>
+          </a:xfrm>
+          <a:prstGeom prst="rect">
+            <a:avLst/>
+          </a:prstGeom>
+          <a:noFill/>
+          <a:ln/>
+        </p:spPr>
+        <p:txBody>
+          <a:bodyPr wrap="square" rtlCol="0" anchor="ctr"/>
+          <a:lstStyle/>
+          <a:p>
+            <a:pPr indent="0" marL="0">
+              <a:buNone/>
+            </a:pPr>
+            <a:r>
+              <a:rPr lang="en-US" sz="1050" dirty="0">
                 <a:solidFill>
                   <a:srgbClr val="FFFFFF"/>
                 </a:solidFill>
@@ -6559,20 +6559,20 @@
               </a:rPr>
               <a:t>1. End Product Quality (30%): Zero-error React 19 + TypeScript production build with rich tactile and acoustic feedback.</a:t>
             </a:r>
-            <a:endParaRPr lang="en-US" sz="1100" dirty="0"/>
-          </a:p>
-          <a:p>
-            <a:pPr indent="0" marL="0">
-              <a:buNone/>
-            </a:pPr>
-            <a:endParaRPr lang="en-US" sz="1100" dirty="0"/>
-          </a:p>
-          <a:p>
-            <a:pPr indent="0" marL="0">
-              <a:buNone/>
-            </a:pPr>
-            <a:r>
-              <a:rPr lang="en-US" sz="1100" dirty="0">
+            <a:endParaRPr lang="en-US" sz="1050" dirty="0"/>
+          </a:p>
+          <a:p>
+            <a:pPr indent="0" marL="0">
+              <a:buNone/>
+            </a:pPr>
+            <a:endParaRPr lang="en-US" sz="1050" dirty="0"/>
+          </a:p>
+          <a:p>
+            <a:pPr indent="0" marL="0">
+              <a:buNone/>
+            </a:pPr>
+            <a:r>
+              <a:rPr lang="en-US" sz="1050" dirty="0">
                 <a:solidFill>
                   <a:srgbClr val="FFFFFF"/>
                 </a:solidFill>
@@ -6582,20 +6582,20 @@
               </a:rPr>
               <a:t>2. Novelty &amp; Impact (20%): Solves the critical real-world crash &amp; blackout context loss problem with zero cloud dependency.</a:t>
             </a:r>
-            <a:endParaRPr lang="en-US" sz="1100" dirty="0"/>
-          </a:p>
-          <a:p>
-            <a:pPr indent="0" marL="0">
-              <a:buNone/>
-            </a:pPr>
-            <a:endParaRPr lang="en-US" sz="1100" dirty="0"/>
-          </a:p>
-          <a:p>
-            <a:pPr indent="0" marL="0">
-              <a:buNone/>
-            </a:pPr>
-            <a:r>
-              <a:rPr lang="en-US" sz="1100" dirty="0">
+            <a:endParaRPr lang="en-US" sz="1050" dirty="0"/>
+          </a:p>
+          <a:p>
+            <a:pPr indent="0" marL="0">
+              <a:buNone/>
+            </a:pPr>
+            <a:endParaRPr lang="en-US" sz="1050" dirty="0"/>
+          </a:p>
+          <a:p>
+            <a:pPr indent="0" marL="0">
+              <a:buNone/>
+            </a:pPr>
+            <a:r>
+              <a:rPr lang="en-US" sz="1050" dirty="0">
                 <a:solidFill>
                   <a:srgbClr val="FFFFFF"/>
                 </a:solidFill>
@@ -6605,20 +6605,20 @@
               </a:rPr>
               <a:t>3. Creative Phone Use (15%): Transforms phone into an emergency code enclave with camera OCR and predictive vault.</a:t>
             </a:r>
-            <a:endParaRPr lang="en-US" sz="1100" dirty="0"/>
-          </a:p>
-          <a:p>
-            <a:pPr indent="0" marL="0">
-              <a:buNone/>
-            </a:pPr>
-            <a:endParaRPr lang="en-US" sz="1100" dirty="0"/>
-          </a:p>
-          <a:p>
-            <a:pPr indent="0" marL="0">
-              <a:buNone/>
-            </a:pPr>
-            <a:r>
-              <a:rPr lang="en-US" sz="1100" dirty="0">
+            <a:endParaRPr lang="en-US" sz="1050" dirty="0"/>
+          </a:p>
+          <a:p>
+            <a:pPr indent="0" marL="0">
+              <a:buNone/>
+            </a:pPr>
+            <a:endParaRPr lang="en-US" sz="1050" dirty="0"/>
+          </a:p>
+          <a:p>
+            <a:pPr indent="0" marL="0">
+              <a:buNone/>
+            </a:pPr>
+            <a:r>
+              <a:rPr lang="en-US" sz="1050" dirty="0">
                 <a:solidFill>
                   <a:srgbClr val="FFFFFF"/>
                 </a:solidFill>
@@ -6628,20 +6628,20 @@
               </a:rPr>
               <a:t>4. Technical Depth (15%): On-device Qwen 2.5-Coder SLM core, Wi-Fi Aware mesh protocol, and 3-way visual Git diff review.</a:t>
             </a:r>
-            <a:endParaRPr lang="en-US" sz="1100" dirty="0"/>
-          </a:p>
-          <a:p>
-            <a:pPr indent="0" marL="0">
-              <a:buNone/>
-            </a:pPr>
-            <a:endParaRPr lang="en-US" sz="1100" dirty="0"/>
-          </a:p>
-          <a:p>
-            <a:pPr indent="0" marL="0">
-              <a:buNone/>
-            </a:pPr>
-            <a:r>
-              <a:rPr lang="en-US" sz="1100" dirty="0">
+            <a:endParaRPr lang="en-US" sz="1050" dirty="0"/>
+          </a:p>
+          <a:p>
+            <a:pPr indent="0" marL="0">
+              <a:buNone/>
+            </a:pPr>
+            <a:endParaRPr lang="en-US" sz="1050" dirty="0"/>
+          </a:p>
+          <a:p>
+            <a:pPr indent="0" marL="0">
+              <a:buNone/>
+            </a:pPr>
+            <a:r>
+              <a:rPr lang="en-US" sz="1050" dirty="0">
                 <a:solidFill>
                   <a:srgbClr val="FFFFFF"/>
                 </a:solidFill>
@@ -6651,20 +6651,20 @@
               </a:rPr>
               <a:t>5. Office Kit Bridge (10%): Seamless bidirectional clipboard and automated Git patch synchronization between laptop and phone.</a:t>
             </a:r>
-            <a:endParaRPr lang="en-US" sz="1100" dirty="0"/>
-          </a:p>
-          <a:p>
-            <a:pPr indent="0" marL="0">
-              <a:buNone/>
-            </a:pPr>
-            <a:endParaRPr lang="en-US" sz="1100" dirty="0"/>
-          </a:p>
-          <a:p>
-            <a:pPr indent="0" marL="0">
-              <a:buNone/>
-            </a:pPr>
-            <a:r>
-              <a:rPr lang="en-US" sz="1100" dirty="0">
+            <a:endParaRPr lang="en-US" sz="1050" dirty="0"/>
+          </a:p>
+          <a:p>
+            <a:pPr indent="0" marL="0">
+              <a:buNone/>
+            </a:pPr>
+            <a:endParaRPr lang="en-US" sz="1050" dirty="0"/>
+          </a:p>
+          <a:p>
+            <a:pPr indent="0" marL="0">
+              <a:buNone/>
+            </a:pPr>
+            <a:r>
+              <a:rPr lang="en-US" sz="1050" dirty="0">
                 <a:solidFill>
                   <a:srgbClr val="FFFFFF"/>
                 </a:solidFill>
@@ -6674,7 +6674,7 @@
               </a:rPr>
               <a:t>6. Presentation (10%): Bulletproof 1-click 4-stage judge demo walkthrough designed for a crisp, memorable 60-second pitch.</a:t>
             </a:r>
-            <a:endParaRPr lang="en-US" sz="1100" dirty="0"/>
+            <a:endParaRPr lang="en-US" sz="1050" dirty="0"/>
           </a:p>
         </p:txBody>
       </p:sp>

</xml_diff>